<commit_message>
some code polishing, comments adn documentation.
</commit_message>
<xml_diff>
--- a/docs/Stock-Exchange-Sim.pptx
+++ b/docs/Stock-Exchange-Sim.pptx
@@ -10,6 +10,8 @@
     <p:sldId id="258" r:id="rId5"/>
     <p:sldId id="259" r:id="rId6"/>
     <p:sldId id="260" r:id="rId7"/>
+    <p:sldId id="261" r:id="rId8"/>
+    <p:sldId id="262" r:id="rId9"/>
   </p:sldIdLst>
   <p:sldSz cx="10080625" cy="5670550"/>
   <p:notesSz cx="7559675" cy="10691813"/>
@@ -45,8 +47,8 @@
         </p:nvSpPr>
         <p:spPr>
           <a:xfrm>
-            <a:off x="504000" y="226080"/>
-            <a:ext cx="9071640" cy="946440"/>
+            <a:off x="504000" y="28800"/>
+            <a:ext cx="9071280" cy="1341000"/>
           </a:xfrm>
           <a:prstGeom prst="rect">
             <a:avLst/>
@@ -87,8 +89,8 @@
         </p:nvSpPr>
         <p:spPr>
           <a:xfrm>
-            <a:off x="504000" y="1326600"/>
-            <a:ext cx="9071640" cy="3288240"/>
+            <a:off x="504000" y="2726280"/>
+            <a:ext cx="9071280" cy="488160"/>
           </a:xfrm>
           <a:prstGeom prst="rect">
             <a:avLst/>
@@ -124,7 +126,7 @@
             <a:spLocks noGrp="1"/>
           </p:cNvSpPr>
           <p:nvPr>
-            <p:ph type="ftr" idx="2"/>
+            <p:ph type="ftr" idx="1"/>
           </p:nvPr>
         </p:nvSpPr>
         <p:spPr/>
@@ -144,14 +146,14 @@
             <a:spLocks noGrp="1"/>
           </p:cNvSpPr>
           <p:nvPr>
-            <p:ph type="sldNum" idx="3"/>
+            <p:ph type="sldNum" idx="2"/>
           </p:nvPr>
         </p:nvSpPr>
         <p:spPr/>
         <p:txBody>
           <a:bodyPr/>
           <a:p>
-            <a:fld id="{C60EABB6-1867-48CA-B044-8AE6FCDD97C4}" type="slidenum">
+            <a:fld id="{D45A69AA-359F-4D6E-BAE1-DF082B006ACA}" type="slidenum">
               <a:t>&lt;#&gt;</a:t>
             </a:fld>
           </a:p>
@@ -164,7 +166,7 @@
             <a:spLocks noGrp="1"/>
           </p:cNvSpPr>
           <p:nvPr>
-            <p:ph type="dt" idx="1"/>
+            <p:ph type="dt" idx="3"/>
           </p:nvPr>
         </p:nvSpPr>
         <p:spPr/>
@@ -212,8 +214,8 @@
         </p:nvSpPr>
         <p:spPr>
           <a:xfrm>
-            <a:off x="504000" y="226080"/>
-            <a:ext cx="9071640" cy="946440"/>
+            <a:off x="504000" y="28800"/>
+            <a:ext cx="9071280" cy="1341000"/>
           </a:xfrm>
           <a:prstGeom prst="rect">
             <a:avLst/>
@@ -225,10 +227,10 @@
         </p:spPr>
         <p:txBody>
           <a:bodyPr lIns="0" tIns="0" rIns="0" bIns="0" anchor="ctr">
-            <a:noAutofit/>
+            <a:spAutoFit/>
           </a:bodyPr>
           <a:lstStyle>
-            <a:lvl1pPr indent="0" algn="ctr">
+            <a:lvl1pPr indent="0" algn="l">
               <a:buNone/>
               <a:defRPr lang="de-DE" sz="4400" b="0" u="none" strike="noStrike">
                 <a:solidFill>
@@ -241,7 +243,7 @@
             </a:lvl1pPr>
           </a:lstStyle>
           <a:p>
-            <a:pPr indent="0" algn="ctr">
+            <a:pPr indent="0" algn="l">
               <a:buNone/>
             </a:pPr>
             <a:r>
@@ -253,513 +255,7 @@
                 <a:uFillTx/>
                 <a:latin typeface="Arial"/>
               </a:rPr>
-              <a:t>F</a:t>
-            </a:r>
-            <a:r>
-              <a:rPr lang="de-DE" sz="4400" b="0" u="none" strike="noStrike">
-                <a:solidFill>
-                  <a:srgbClr val="000000"/>
-                </a:solidFill>
-                <a:effectLst/>
-                <a:uFillTx/>
-                <a:latin typeface="Arial"/>
-              </a:rPr>
-              <a:t>o</a:t>
-            </a:r>
-            <a:r>
-              <a:rPr lang="de-DE" sz="4400" b="0" u="none" strike="noStrike">
-                <a:solidFill>
-                  <a:srgbClr val="000000"/>
-                </a:solidFill>
-                <a:effectLst/>
-                <a:uFillTx/>
-                <a:latin typeface="Arial"/>
-              </a:rPr>
-              <a:t>r</a:t>
-            </a:r>
-            <a:r>
-              <a:rPr lang="de-DE" sz="4400" b="0" u="none" strike="noStrike">
-                <a:solidFill>
-                  <a:srgbClr val="000000"/>
-                </a:solidFill>
-                <a:effectLst/>
-                <a:uFillTx/>
-                <a:latin typeface="Arial"/>
-              </a:rPr>
-              <a:t>m</a:t>
-            </a:r>
-            <a:r>
-              <a:rPr lang="de-DE" sz="4400" b="0" u="none" strike="noStrike">
-                <a:solidFill>
-                  <a:srgbClr val="000000"/>
-                </a:solidFill>
-                <a:effectLst/>
-                <a:uFillTx/>
-                <a:latin typeface="Arial"/>
-              </a:rPr>
-              <a:t>a</a:t>
-            </a:r>
-            <a:r>
-              <a:rPr lang="de-DE" sz="4400" b="0" u="none" strike="noStrike">
-                <a:solidFill>
-                  <a:srgbClr val="000000"/>
-                </a:solidFill>
-                <a:effectLst/>
-                <a:uFillTx/>
-                <a:latin typeface="Arial"/>
-              </a:rPr>
-              <a:t>t</a:t>
-            </a:r>
-            <a:r>
-              <a:rPr lang="de-DE" sz="4400" b="0" u="none" strike="noStrike">
-                <a:solidFill>
-                  <a:srgbClr val="000000"/>
-                </a:solidFill>
-                <a:effectLst/>
-                <a:uFillTx/>
-                <a:latin typeface="Arial"/>
-              </a:rPr>
-              <a:t> </a:t>
-            </a:r>
-            <a:r>
-              <a:rPr lang="de-DE" sz="4400" b="0" u="none" strike="noStrike">
-                <a:solidFill>
-                  <a:srgbClr val="000000"/>
-                </a:solidFill>
-                <a:effectLst/>
-                <a:uFillTx/>
-                <a:latin typeface="Arial"/>
-              </a:rPr>
-              <a:t>d</a:t>
-            </a:r>
-            <a:r>
-              <a:rPr lang="de-DE" sz="4400" b="0" u="none" strike="noStrike">
-                <a:solidFill>
-                  <a:srgbClr val="000000"/>
-                </a:solidFill>
-                <a:effectLst/>
-                <a:uFillTx/>
-                <a:latin typeface="Arial"/>
-              </a:rPr>
-              <a:t>e</a:t>
-            </a:r>
-            <a:r>
-              <a:rPr lang="de-DE" sz="4400" b="0" u="none" strike="noStrike">
-                <a:solidFill>
-                  <a:srgbClr val="000000"/>
-                </a:solidFill>
-                <a:effectLst/>
-                <a:uFillTx/>
-                <a:latin typeface="Arial"/>
-              </a:rPr>
-              <a:t>s</a:t>
-            </a:r>
-            <a:r>
-              <a:rPr lang="de-DE" sz="4400" b="0" u="none" strike="noStrike">
-                <a:solidFill>
-                  <a:srgbClr val="000000"/>
-                </a:solidFill>
-                <a:effectLst/>
-                <a:uFillTx/>
-                <a:latin typeface="Arial"/>
-              </a:rPr>
-              <a:t> </a:t>
-            </a:r>
-            <a:r>
-              <a:rPr lang="de-DE" sz="4400" b="0" u="none" strike="noStrike">
-                <a:solidFill>
-                  <a:srgbClr val="000000"/>
-                </a:solidFill>
-                <a:effectLst/>
-                <a:uFillTx/>
-                <a:latin typeface="Arial"/>
-              </a:rPr>
-              <a:t>T</a:t>
-            </a:r>
-            <a:r>
-              <a:rPr lang="de-DE" sz="4400" b="0" u="none" strike="noStrike">
-                <a:solidFill>
-                  <a:srgbClr val="000000"/>
-                </a:solidFill>
-                <a:effectLst/>
-                <a:uFillTx/>
-                <a:latin typeface="Arial"/>
-              </a:rPr>
-              <a:t>i</a:t>
-            </a:r>
-            <a:r>
-              <a:rPr lang="de-DE" sz="4400" b="0" u="none" strike="noStrike">
-                <a:solidFill>
-                  <a:srgbClr val="000000"/>
-                </a:solidFill>
-                <a:effectLst/>
-                <a:uFillTx/>
-                <a:latin typeface="Arial"/>
-              </a:rPr>
-              <a:t>t</a:t>
-            </a:r>
-            <a:r>
-              <a:rPr lang="de-DE" sz="4400" b="0" u="none" strike="noStrike">
-                <a:solidFill>
-                  <a:srgbClr val="000000"/>
-                </a:solidFill>
-                <a:effectLst/>
-                <a:uFillTx/>
-                <a:latin typeface="Arial"/>
-              </a:rPr>
-              <a:t>e</a:t>
-            </a:r>
-            <a:r>
-              <a:rPr lang="de-DE" sz="4400" b="0" u="none" strike="noStrike">
-                <a:solidFill>
-                  <a:srgbClr val="000000"/>
-                </a:solidFill>
-                <a:effectLst/>
-                <a:uFillTx/>
-                <a:latin typeface="Arial"/>
-              </a:rPr>
-              <a:t>l</a:t>
-            </a:r>
-            <a:r>
-              <a:rPr lang="de-DE" sz="4400" b="0" u="none" strike="noStrike">
-                <a:solidFill>
-                  <a:srgbClr val="000000"/>
-                </a:solidFill>
-                <a:effectLst/>
-                <a:uFillTx/>
-                <a:latin typeface="Arial"/>
-              </a:rPr>
-              <a:t>t</a:t>
-            </a:r>
-            <a:r>
-              <a:rPr lang="de-DE" sz="4400" b="0" u="none" strike="noStrike">
-                <a:solidFill>
-                  <a:srgbClr val="000000"/>
-                </a:solidFill>
-                <a:effectLst/>
-                <a:uFillTx/>
-                <a:latin typeface="Arial"/>
-              </a:rPr>
-              <a:t>e</a:t>
-            </a:r>
-            <a:r>
-              <a:rPr lang="de-DE" sz="4400" b="0" u="none" strike="noStrike">
-                <a:solidFill>
-                  <a:srgbClr val="000000"/>
-                </a:solidFill>
-                <a:effectLst/>
-                <a:uFillTx/>
-                <a:latin typeface="Arial"/>
-              </a:rPr>
-              <a:t>x</a:t>
-            </a:r>
-            <a:r>
-              <a:rPr lang="de-DE" sz="4400" b="0" u="none" strike="noStrike">
-                <a:solidFill>
-                  <a:srgbClr val="000000"/>
-                </a:solidFill>
-                <a:effectLst/>
-                <a:uFillTx/>
-                <a:latin typeface="Arial"/>
-              </a:rPr>
-              <a:t>t</a:t>
-            </a:r>
-            <a:r>
-              <a:rPr lang="de-DE" sz="4400" b="0" u="none" strike="noStrike">
-                <a:solidFill>
-                  <a:srgbClr val="000000"/>
-                </a:solidFill>
-                <a:effectLst/>
-                <a:uFillTx/>
-                <a:latin typeface="Arial"/>
-              </a:rPr>
-              <a:t>e</a:t>
-            </a:r>
-            <a:r>
-              <a:rPr lang="de-DE" sz="4400" b="0" u="none" strike="noStrike">
-                <a:solidFill>
-                  <a:srgbClr val="000000"/>
-                </a:solidFill>
-                <a:effectLst/>
-                <a:uFillTx/>
-                <a:latin typeface="Arial"/>
-              </a:rPr>
-              <a:t>s</a:t>
-            </a:r>
-            <a:r>
-              <a:rPr lang="de-DE" sz="4400" b="0" u="none" strike="noStrike">
-                <a:solidFill>
-                  <a:srgbClr val="000000"/>
-                </a:solidFill>
-                <a:effectLst/>
-                <a:uFillTx/>
-                <a:latin typeface="Arial"/>
-              </a:rPr>
-              <a:t> </a:t>
-            </a:r>
-            <a:r>
-              <a:rPr lang="de-DE" sz="4400" b="0" u="none" strike="noStrike">
-                <a:solidFill>
-                  <a:srgbClr val="000000"/>
-                </a:solidFill>
-                <a:effectLst/>
-                <a:uFillTx/>
-                <a:latin typeface="Arial"/>
-              </a:rPr>
-              <a:t>d</a:t>
-            </a:r>
-            <a:r>
-              <a:rPr lang="de-DE" sz="4400" b="0" u="none" strike="noStrike">
-                <a:solidFill>
-                  <a:srgbClr val="000000"/>
-                </a:solidFill>
-                <a:effectLst/>
-                <a:uFillTx/>
-                <a:latin typeface="Arial"/>
-              </a:rPr>
-              <a:t>u</a:t>
-            </a:r>
-            <a:r>
-              <a:rPr lang="de-DE" sz="4400" b="0" u="none" strike="noStrike">
-                <a:solidFill>
-                  <a:srgbClr val="000000"/>
-                </a:solidFill>
-                <a:effectLst/>
-                <a:uFillTx/>
-                <a:latin typeface="Arial"/>
-              </a:rPr>
-              <a:t>r</a:t>
-            </a:r>
-            <a:r>
-              <a:rPr lang="de-DE" sz="4400" b="0" u="none" strike="noStrike">
-                <a:solidFill>
-                  <a:srgbClr val="000000"/>
-                </a:solidFill>
-                <a:effectLst/>
-                <a:uFillTx/>
-                <a:latin typeface="Arial"/>
-              </a:rPr>
-              <a:t>c</a:t>
-            </a:r>
-            <a:r>
-              <a:rPr lang="de-DE" sz="4400" b="0" u="none" strike="noStrike">
-                <a:solidFill>
-                  <a:srgbClr val="000000"/>
-                </a:solidFill>
-                <a:effectLst/>
-                <a:uFillTx/>
-                <a:latin typeface="Arial"/>
-              </a:rPr>
-              <a:t>h</a:t>
-            </a:r>
-            <a:r>
-              <a:rPr lang="de-DE" sz="4400" b="0" u="none" strike="noStrike">
-                <a:solidFill>
-                  <a:srgbClr val="000000"/>
-                </a:solidFill>
-                <a:effectLst/>
-                <a:uFillTx/>
-                <a:latin typeface="Arial"/>
-              </a:rPr>
-              <a:t> </a:t>
-            </a:r>
-            <a:r>
-              <a:rPr lang="de-DE" sz="4400" b="0" u="none" strike="noStrike">
-                <a:solidFill>
-                  <a:srgbClr val="000000"/>
-                </a:solidFill>
-                <a:effectLst/>
-                <a:uFillTx/>
-                <a:latin typeface="Arial"/>
-              </a:rPr>
-              <a:t>K</a:t>
-            </a:r>
-            <a:r>
-              <a:rPr lang="de-DE" sz="4400" b="0" u="none" strike="noStrike">
-                <a:solidFill>
-                  <a:srgbClr val="000000"/>
-                </a:solidFill>
-                <a:effectLst/>
-                <a:uFillTx/>
-                <a:latin typeface="Arial"/>
-              </a:rPr>
-              <a:t>l</a:t>
-            </a:r>
-            <a:r>
-              <a:rPr lang="de-DE" sz="4400" b="0" u="none" strike="noStrike">
-                <a:solidFill>
-                  <a:srgbClr val="000000"/>
-                </a:solidFill>
-                <a:effectLst/>
-                <a:uFillTx/>
-                <a:latin typeface="Arial"/>
-              </a:rPr>
-              <a:t>i</a:t>
-            </a:r>
-            <a:r>
-              <a:rPr lang="de-DE" sz="4400" b="0" u="none" strike="noStrike">
-                <a:solidFill>
-                  <a:srgbClr val="000000"/>
-                </a:solidFill>
-                <a:effectLst/>
-                <a:uFillTx/>
-                <a:latin typeface="Arial"/>
-              </a:rPr>
-              <a:t>c</a:t>
-            </a:r>
-            <a:r>
-              <a:rPr lang="de-DE" sz="4400" b="0" u="none" strike="noStrike">
-                <a:solidFill>
-                  <a:srgbClr val="000000"/>
-                </a:solidFill>
-                <a:effectLst/>
-                <a:uFillTx/>
-                <a:latin typeface="Arial"/>
-              </a:rPr>
-              <a:t>k</a:t>
-            </a:r>
-            <a:r>
-              <a:rPr lang="de-DE" sz="4400" b="0" u="none" strike="noStrike">
-                <a:solidFill>
-                  <a:srgbClr val="000000"/>
-                </a:solidFill>
-                <a:effectLst/>
-                <a:uFillTx/>
-                <a:latin typeface="Arial"/>
-              </a:rPr>
-              <a:t>e</a:t>
-            </a:r>
-            <a:r>
-              <a:rPr lang="de-DE" sz="4400" b="0" u="none" strike="noStrike">
-                <a:solidFill>
-                  <a:srgbClr val="000000"/>
-                </a:solidFill>
-                <a:effectLst/>
-                <a:uFillTx/>
-                <a:latin typeface="Arial"/>
-              </a:rPr>
-              <a:t>n</a:t>
-            </a:r>
-            <a:r>
-              <a:rPr lang="de-DE" sz="4400" b="0" u="none" strike="noStrike">
-                <a:solidFill>
-                  <a:srgbClr val="000000"/>
-                </a:solidFill>
-                <a:effectLst/>
-                <a:uFillTx/>
-                <a:latin typeface="Arial"/>
-              </a:rPr>
-              <a:t> </a:t>
-            </a:r>
-            <a:r>
-              <a:rPr lang="de-DE" sz="4400" b="0" u="none" strike="noStrike">
-                <a:solidFill>
-                  <a:srgbClr val="000000"/>
-                </a:solidFill>
-                <a:effectLst/>
-                <a:uFillTx/>
-                <a:latin typeface="Arial"/>
-              </a:rPr>
-              <a:t>b</a:t>
-            </a:r>
-            <a:r>
-              <a:rPr lang="de-DE" sz="4400" b="0" u="none" strike="noStrike">
-                <a:solidFill>
-                  <a:srgbClr val="000000"/>
-                </a:solidFill>
-                <a:effectLst/>
-                <a:uFillTx/>
-                <a:latin typeface="Arial"/>
-              </a:rPr>
-              <a:t>e</a:t>
-            </a:r>
-            <a:r>
-              <a:rPr lang="de-DE" sz="4400" b="0" u="none" strike="noStrike">
-                <a:solidFill>
-                  <a:srgbClr val="000000"/>
-                </a:solidFill>
-                <a:effectLst/>
-                <a:uFillTx/>
-                <a:latin typeface="Arial"/>
-              </a:rPr>
-              <a:t>a</a:t>
-            </a:r>
-            <a:r>
-              <a:rPr lang="de-DE" sz="4400" b="0" u="none" strike="noStrike">
-                <a:solidFill>
-                  <a:srgbClr val="000000"/>
-                </a:solidFill>
-                <a:effectLst/>
-                <a:uFillTx/>
-                <a:latin typeface="Arial"/>
-              </a:rPr>
-              <a:t>r</a:t>
-            </a:r>
-            <a:r>
-              <a:rPr lang="de-DE" sz="4400" b="0" u="none" strike="noStrike">
-                <a:solidFill>
-                  <a:srgbClr val="000000"/>
-                </a:solidFill>
-                <a:effectLst/>
-                <a:uFillTx/>
-                <a:latin typeface="Arial"/>
-              </a:rPr>
-              <a:t>b</a:t>
-            </a:r>
-            <a:r>
-              <a:rPr lang="de-DE" sz="4400" b="0" u="none" strike="noStrike">
-                <a:solidFill>
-                  <a:srgbClr val="000000"/>
-                </a:solidFill>
-                <a:effectLst/>
-                <a:uFillTx/>
-                <a:latin typeface="Arial"/>
-              </a:rPr>
-              <a:t>e</a:t>
-            </a:r>
-            <a:r>
-              <a:rPr lang="de-DE" sz="4400" b="0" u="none" strike="noStrike">
-                <a:solidFill>
-                  <a:srgbClr val="000000"/>
-                </a:solidFill>
-                <a:effectLst/>
-                <a:uFillTx/>
-                <a:latin typeface="Arial"/>
-              </a:rPr>
-              <a:t>i</a:t>
-            </a:r>
-            <a:r>
-              <a:rPr lang="de-DE" sz="4400" b="0" u="none" strike="noStrike">
-                <a:solidFill>
-                  <a:srgbClr val="000000"/>
-                </a:solidFill>
-                <a:effectLst/>
-                <a:uFillTx/>
-                <a:latin typeface="Arial"/>
-              </a:rPr>
-              <a:t>t</a:t>
-            </a:r>
-            <a:r>
-              <a:rPr lang="de-DE" sz="4400" b="0" u="none" strike="noStrike">
-                <a:solidFill>
-                  <a:srgbClr val="000000"/>
-                </a:solidFill>
-                <a:effectLst/>
-                <a:uFillTx/>
-                <a:latin typeface="Arial"/>
-              </a:rPr>
-              <a:t>e</a:t>
-            </a:r>
-            <a:r>
-              <a:rPr lang="de-DE" sz="4400" b="0" u="none" strike="noStrike">
-                <a:solidFill>
-                  <a:srgbClr val="000000"/>
-                </a:solidFill>
-                <a:effectLst/>
-                <a:uFillTx/>
-                <a:latin typeface="Arial"/>
-              </a:rPr>
-              <a:t>n</a:t>
+              <a:t>Format des Titeltextes durch Klicken bearbeiten</a:t>
             </a:r>
             <a:endParaRPr lang="de-DE" sz="4400" b="0" u="none" strike="noStrike">
               <a:solidFill>
@@ -775,6 +271,228 @@
       <p:sp>
         <p:nvSpPr>
           <p:cNvPr id="3" name="PlaceHolder 2"/>
+          <p:cNvSpPr>
+            <a:spLocks noGrp="1"/>
+          </p:cNvSpPr>
+          <p:nvPr>
+            <p:ph type="ftr" idx="1"/>
+          </p:nvPr>
+        </p:nvSpPr>
+        <p:spPr>
+          <a:xfrm>
+            <a:off x="3447360" y="5165280"/>
+            <a:ext cx="3194640" cy="390240"/>
+          </a:xfrm>
+          <a:prstGeom prst="rect">
+            <a:avLst/>
+          </a:prstGeom>
+          <a:noFill/>
+          <a:ln w="0">
+            <a:noFill/>
+          </a:ln>
+        </p:spPr>
+        <p:txBody>
+          <a:bodyPr lIns="0" tIns="0" rIns="0" bIns="0" anchor="t">
+            <a:noAutofit/>
+          </a:bodyPr>
+          <a:lstStyle>
+            <a:lvl1pPr indent="0" algn="ctr">
+              <a:lnSpc>
+                <a:spcPct val="100000"/>
+              </a:lnSpc>
+              <a:buNone/>
+              <a:tabLst>
+                <a:tab pos="0" algn="l"/>
+              </a:tabLst>
+              <a:defRPr lang="de-DE" sz="1400" b="0" u="none" strike="noStrike">
+                <a:solidFill>
+                  <a:srgbClr val="000000"/>
+                </a:solidFill>
+                <a:effectLst/>
+                <a:uFillTx/>
+                <a:latin typeface="Times New Roman"/>
+              </a:defRPr>
+            </a:lvl1pPr>
+          </a:lstStyle>
+          <a:p>
+            <a:pPr indent="0" algn="ctr">
+              <a:lnSpc>
+                <a:spcPct val="100000"/>
+              </a:lnSpc>
+              <a:buNone/>
+              <a:tabLst>
+                <a:tab pos="0" algn="l"/>
+              </a:tabLst>
+            </a:pPr>
+            <a:r>
+              <a:rPr lang="de-DE" sz="1400" b="0" u="none" strike="noStrike">
+                <a:solidFill>
+                  <a:srgbClr val="000000"/>
+                </a:solidFill>
+                <a:effectLst/>
+                <a:uFillTx/>
+                <a:latin typeface="Times New Roman"/>
+              </a:rPr>
+              <a:t>&lt;Fußzeile&gt;</a:t>
+            </a:r>
+            <a:endParaRPr lang="de-DE" sz="1400" b="0" u="none" strike="noStrike">
+              <a:solidFill>
+                <a:srgbClr val="000000"/>
+              </a:solidFill>
+              <a:effectLst/>
+              <a:uFillTx/>
+              <a:latin typeface="Times New Roman"/>
+            </a:endParaRPr>
+          </a:p>
+        </p:txBody>
+      </p:sp>
+      <p:sp>
+        <p:nvSpPr>
+          <p:cNvPr id="4" name="PlaceHolder 3"/>
+          <p:cNvSpPr>
+            <a:spLocks noGrp="1"/>
+          </p:cNvSpPr>
+          <p:nvPr>
+            <p:ph type="sldNum" idx="2"/>
+          </p:nvPr>
+        </p:nvSpPr>
+        <p:spPr>
+          <a:xfrm>
+            <a:off x="7227360" y="5165280"/>
+            <a:ext cx="2347920" cy="390240"/>
+          </a:xfrm>
+          <a:prstGeom prst="rect">
+            <a:avLst/>
+          </a:prstGeom>
+          <a:noFill/>
+          <a:ln w="0">
+            <a:noFill/>
+          </a:ln>
+        </p:spPr>
+        <p:txBody>
+          <a:bodyPr lIns="0" tIns="0" rIns="0" bIns="0" anchor="t">
+            <a:noAutofit/>
+          </a:bodyPr>
+          <a:lstStyle>
+            <a:lvl1pPr indent="0" algn="r">
+              <a:lnSpc>
+                <a:spcPct val="100000"/>
+              </a:lnSpc>
+              <a:buNone/>
+              <a:tabLst>
+                <a:tab pos="0" algn="l"/>
+              </a:tabLst>
+              <a:defRPr lang="de-DE" sz="1400" b="0" u="none" strike="noStrike">
+                <a:solidFill>
+                  <a:srgbClr val="000000"/>
+                </a:solidFill>
+                <a:effectLst/>
+                <a:uFillTx/>
+                <a:latin typeface="Times New Roman"/>
+              </a:defRPr>
+            </a:lvl1pPr>
+          </a:lstStyle>
+          <a:p>
+            <a:pPr indent="0" algn="r">
+              <a:lnSpc>
+                <a:spcPct val="100000"/>
+              </a:lnSpc>
+              <a:buNone/>
+              <a:tabLst>
+                <a:tab pos="0" algn="l"/>
+              </a:tabLst>
+            </a:pPr>
+            <a:fld id="{D785937B-F156-4EB9-B7FA-63F9851AB561}" type="slidenum">
+              <a:rPr lang="de-DE" sz="1400" b="0" u="none" strike="noStrike">
+                <a:solidFill>
+                  <a:srgbClr val="000000"/>
+                </a:solidFill>
+                <a:effectLst/>
+                <a:uFillTx/>
+                <a:latin typeface="Times New Roman"/>
+              </a:rPr>
+              <a:t>&lt;Foliennummer&gt;</a:t>
+            </a:fld>
+            <a:endParaRPr lang="de-DE" sz="1400" b="0" u="none" strike="noStrike">
+              <a:solidFill>
+                <a:srgbClr val="000000"/>
+              </a:solidFill>
+              <a:effectLst/>
+              <a:uFillTx/>
+              <a:latin typeface="Times New Roman"/>
+            </a:endParaRPr>
+          </a:p>
+        </p:txBody>
+      </p:sp>
+      <p:sp>
+        <p:nvSpPr>
+          <p:cNvPr id="5" name="PlaceHolder 4"/>
+          <p:cNvSpPr>
+            <a:spLocks noGrp="1"/>
+          </p:cNvSpPr>
+          <p:nvPr>
+            <p:ph type="dt" idx="3"/>
+          </p:nvPr>
+        </p:nvSpPr>
+        <p:spPr>
+          <a:xfrm>
+            <a:off x="504000" y="5165280"/>
+            <a:ext cx="2347920" cy="390240"/>
+          </a:xfrm>
+          <a:prstGeom prst="rect">
+            <a:avLst/>
+          </a:prstGeom>
+          <a:noFill/>
+          <a:ln w="0">
+            <a:noFill/>
+          </a:ln>
+        </p:spPr>
+        <p:txBody>
+          <a:bodyPr lIns="0" tIns="0" rIns="0" bIns="0" anchor="t">
+            <a:noAutofit/>
+          </a:bodyPr>
+          <a:lstStyle>
+            <a:lvl1pPr indent="0" algn="l">
+              <a:buNone/>
+              <a:defRPr lang="de-DE" sz="1400" b="0" u="none" strike="noStrike">
+                <a:solidFill>
+                  <a:srgbClr val="000000"/>
+                </a:solidFill>
+                <a:effectLst/>
+                <a:uFillTx/>
+                <a:latin typeface="Times New Roman"/>
+              </a:defRPr>
+            </a:lvl1pPr>
+          </a:lstStyle>
+          <a:p>
+            <a:pPr indent="0" algn="l">
+              <a:buNone/>
+            </a:pPr>
+            <a:r>
+              <a:rPr lang="de-DE" sz="1400" b="0" u="none" strike="noStrike">
+                <a:solidFill>
+                  <a:srgbClr val="000000"/>
+                </a:solidFill>
+                <a:effectLst/>
+                <a:uFillTx/>
+                <a:latin typeface="Times New Roman"/>
+              </a:rPr>
+              <a:t>&lt;Datum/Uhrzeit&gt;</a:t>
+            </a:r>
+            <a:endParaRPr lang="de-DE" sz="1400" b="0" u="none" strike="noStrike">
+              <a:solidFill>
+                <a:srgbClr val="000000"/>
+              </a:solidFill>
+              <a:effectLst/>
+              <a:uFillTx/>
+              <a:latin typeface="Times New Roman"/>
+            </a:endParaRPr>
+          </a:p>
+        </p:txBody>
+      </p:sp>
+      <p:sp>
+        <p:nvSpPr>
+          <p:cNvPr id="6" name="PlaceHolder 5"/>
           <p:cNvSpPr>
             <a:spLocks noGrp="1"/>
           </p:cNvSpPr>
@@ -785,7 +503,7 @@
         <p:spPr>
           <a:xfrm>
             <a:off x="504000" y="1326600"/>
-            <a:ext cx="9071640" cy="3288240"/>
+            <a:ext cx="9072000" cy="3288600"/>
           </a:xfrm>
           <a:prstGeom prst="rect">
             <a:avLst/>
@@ -1156,204 +874,6 @@
               <a:effectLst/>
               <a:uFillTx/>
               <a:latin typeface="Arial"/>
-            </a:endParaRPr>
-          </a:p>
-        </p:txBody>
-      </p:sp>
-      <p:sp>
-        <p:nvSpPr>
-          <p:cNvPr id="4" name="PlaceHolder 3"/>
-          <p:cNvSpPr>
-            <a:spLocks noGrp="1"/>
-          </p:cNvSpPr>
-          <p:nvPr>
-            <p:ph type="dt" idx="1"/>
-          </p:nvPr>
-        </p:nvSpPr>
-        <p:spPr>
-          <a:xfrm>
-            <a:off x="504000" y="5165280"/>
-            <a:ext cx="2348280" cy="390600"/>
-          </a:xfrm>
-          <a:prstGeom prst="rect">
-            <a:avLst/>
-          </a:prstGeom>
-          <a:noFill/>
-          <a:ln w="0">
-            <a:noFill/>
-          </a:ln>
-        </p:spPr>
-        <p:txBody>
-          <a:bodyPr lIns="0" tIns="0" rIns="0" bIns="0" anchor="t">
-            <a:noAutofit/>
-          </a:bodyPr>
-          <a:lstStyle>
-            <a:lvl1pPr indent="0" algn="l">
-              <a:buNone/>
-              <a:defRPr lang="de-DE" sz="1400" b="0" u="none" strike="noStrike">
-                <a:solidFill>
-                  <a:srgbClr val="000000"/>
-                </a:solidFill>
-                <a:effectLst/>
-                <a:uFillTx/>
-                <a:latin typeface="Times New Roman"/>
-              </a:defRPr>
-            </a:lvl1pPr>
-          </a:lstStyle>
-          <a:p>
-            <a:pPr indent="0" algn="l">
-              <a:buNone/>
-            </a:pPr>
-            <a:r>
-              <a:rPr lang="de-DE" sz="1400" b="0" u="none" strike="noStrike">
-                <a:solidFill>
-                  <a:srgbClr val="000000"/>
-                </a:solidFill>
-                <a:effectLst/>
-                <a:uFillTx/>
-                <a:latin typeface="Times New Roman"/>
-              </a:rPr>
-              <a:t>&lt;Datum/Uhrzeit&gt;</a:t>
-            </a:r>
-            <a:endParaRPr lang="de-DE" sz="1400" b="0" u="none" strike="noStrike">
-              <a:solidFill>
-                <a:srgbClr val="000000"/>
-              </a:solidFill>
-              <a:effectLst/>
-              <a:uFillTx/>
-              <a:latin typeface="Times New Roman"/>
-            </a:endParaRPr>
-          </a:p>
-        </p:txBody>
-      </p:sp>
-      <p:sp>
-        <p:nvSpPr>
-          <p:cNvPr id="5" name="PlaceHolder 4"/>
-          <p:cNvSpPr>
-            <a:spLocks noGrp="1"/>
-          </p:cNvSpPr>
-          <p:nvPr>
-            <p:ph type="ftr" idx="2"/>
-          </p:nvPr>
-        </p:nvSpPr>
-        <p:spPr>
-          <a:xfrm>
-            <a:off x="3447360" y="5165280"/>
-            <a:ext cx="3195000" cy="390600"/>
-          </a:xfrm>
-          <a:prstGeom prst="rect">
-            <a:avLst/>
-          </a:prstGeom>
-          <a:noFill/>
-          <a:ln w="0">
-            <a:noFill/>
-          </a:ln>
-        </p:spPr>
-        <p:txBody>
-          <a:bodyPr lIns="0" tIns="0" rIns="0" bIns="0" anchor="t">
-            <a:noAutofit/>
-          </a:bodyPr>
-          <a:lstStyle>
-            <a:lvl1pPr indent="0" algn="ctr">
-              <a:buNone/>
-              <a:defRPr lang="de-DE" sz="1400" b="0" u="none" strike="noStrike">
-                <a:solidFill>
-                  <a:srgbClr val="000000"/>
-                </a:solidFill>
-                <a:effectLst/>
-                <a:uFillTx/>
-                <a:latin typeface="Times New Roman"/>
-              </a:defRPr>
-            </a:lvl1pPr>
-          </a:lstStyle>
-          <a:p>
-            <a:pPr indent="0" algn="ctr">
-              <a:buNone/>
-            </a:pPr>
-            <a:r>
-              <a:rPr lang="de-DE" sz="1400" b="0" u="none" strike="noStrike">
-                <a:solidFill>
-                  <a:srgbClr val="000000"/>
-                </a:solidFill>
-                <a:effectLst/>
-                <a:uFillTx/>
-                <a:latin typeface="Times New Roman"/>
-              </a:rPr>
-              <a:t>&lt;Fußzeile&gt;</a:t>
-            </a:r>
-            <a:endParaRPr lang="de-DE" sz="1400" b="0" u="none" strike="noStrike">
-              <a:solidFill>
-                <a:srgbClr val="000000"/>
-              </a:solidFill>
-              <a:effectLst/>
-              <a:uFillTx/>
-              <a:latin typeface="Times New Roman"/>
-            </a:endParaRPr>
-          </a:p>
-        </p:txBody>
-      </p:sp>
-      <p:sp>
-        <p:nvSpPr>
-          <p:cNvPr id="6" name="PlaceHolder 5"/>
-          <p:cNvSpPr>
-            <a:spLocks noGrp="1"/>
-          </p:cNvSpPr>
-          <p:nvPr>
-            <p:ph type="sldNum" idx="3"/>
-          </p:nvPr>
-        </p:nvSpPr>
-        <p:spPr>
-          <a:xfrm>
-            <a:off x="7227360" y="5165280"/>
-            <a:ext cx="2348280" cy="390600"/>
-          </a:xfrm>
-          <a:prstGeom prst="rect">
-            <a:avLst/>
-          </a:prstGeom>
-          <a:noFill/>
-          <a:ln w="0">
-            <a:noFill/>
-          </a:ln>
-        </p:spPr>
-        <p:txBody>
-          <a:bodyPr lIns="0" tIns="0" rIns="0" bIns="0" anchor="t">
-            <a:noAutofit/>
-          </a:bodyPr>
-          <a:lstStyle>
-            <a:lvl1pPr indent="0" algn="r">
-              <a:buNone/>
-              <a:defRPr lang="de-DE" sz="1400" b="0" u="none" strike="noStrike">
-                <a:solidFill>
-                  <a:srgbClr val="000000"/>
-                </a:solidFill>
-                <a:effectLst/>
-                <a:uFillTx/>
-                <a:latin typeface="Times New Roman"/>
-              </a:defRPr>
-            </a:lvl1pPr>
-          </a:lstStyle>
-          <a:p>
-            <a:pPr indent="0" algn="r">
-              <a:buNone/>
-            </a:pPr>
-            <a:fld id="{0DAFE297-51F7-4951-A306-9C69F96D5CC9}" type="slidenum">
-              <a:rPr lang="de-DE" sz="1400" b="0" u="none" strike="noStrike">
-                <a:solidFill>
-                  <a:srgbClr val="000000"/>
-                </a:solidFill>
-                <a:effectLst/>
-                <a:uFillTx/>
-                <a:latin typeface="Times New Roman"/>
-              </a:rPr>
-              <a:t>&lt;Foliennummer&gt;</a:t>
-            </a:fld>
-            <a:endParaRPr lang="de-DE" sz="1400" b="0" u="none" strike="noStrike">
-              <a:solidFill>
-                <a:srgbClr val="000000"/>
-              </a:solidFill>
-              <a:effectLst/>
-              <a:uFillTx/>
-              <a:latin typeface="Times New Roman"/>
             </a:endParaRPr>
           </a:p>
         </p:txBody>
@@ -1414,7 +934,7 @@
         <p:spPr>
           <a:xfrm>
             <a:off x="46800" y="180000"/>
-            <a:ext cx="9925200" cy="5334480"/>
+            <a:ext cx="9924840" cy="5334120"/>
           </a:xfrm>
           <a:prstGeom prst="rect">
             <a:avLst/>
@@ -1485,7 +1005,7 @@
         <p:spPr>
           <a:xfrm>
             <a:off x="82800" y="150840"/>
-            <a:ext cx="9900000" cy="5321160"/>
+            <a:ext cx="9899640" cy="5320800"/>
           </a:xfrm>
           <a:prstGeom prst="rect">
             <a:avLst/>
@@ -1556,7 +1076,7 @@
         <p:spPr>
           <a:xfrm>
             <a:off x="109440" y="180000"/>
-            <a:ext cx="9995760" cy="5372640"/>
+            <a:ext cx="9995400" cy="5372280"/>
           </a:xfrm>
           <a:prstGeom prst="rect">
             <a:avLst/>
@@ -1627,7 +1147,7 @@
         <p:spPr>
           <a:xfrm>
             <a:off x="37440" y="144000"/>
-            <a:ext cx="9995760" cy="5372640"/>
+            <a:ext cx="9995400" cy="5372280"/>
           </a:xfrm>
           <a:prstGeom prst="rect">
             <a:avLst/>
@@ -1652,6 +1172,100 @@
 </file>
 
 <file path=ppt/slides/slide5.xml><?xml version="1.0" encoding="utf-8"?>
+<p:sld xmlns:a="http://schemas.openxmlformats.org/drawingml/2006/main" xmlns:p="http://schemas.openxmlformats.org/presentationml/2006/main" xmlns:r="http://schemas.openxmlformats.org/officeDocument/2006/relationships" xmlns:p14="http://schemas.microsoft.com/office/powerpoint/2010/main" xmlns:p15="http://schemas.microsoft.com/office/powerpoint/2012/main" xmlns:mc="http://schemas.openxmlformats.org/markup-compatibility/2006">
+  <p:cSld>
+    <p:bg>
+      <p:bgPr>
+        <a:gradFill rotWithShape="0">
+          <a:gsLst>
+            <a:gs pos="0">
+              <a:srgbClr val="729FCF"/>
+            </a:gs>
+            <a:gs pos="100000">
+              <a:srgbClr val="000000"/>
+            </a:gs>
+          </a:gsLst>
+          <a:path path="circle">
+            <a:fillToRect l="50000" t="50000" r="50000" b="50000"/>
+          </a:path>
+        </a:gradFill>
+      </p:bgPr>
+    </p:bg>
+    <p:spTree>
+      <p:nvGrpSpPr>
+        <p:cNvPr id="1" name=""/>
+        <p:cNvGrpSpPr/>
+        <p:nvPr/>
+      </p:nvGrpSpPr>
+      <p:grpSpPr>
+        <a:xfrm>
+          <a:off x="0" y="0"/>
+          <a:ext cx="0" cy="0"/>
+          <a:chOff x="0" y="0"/>
+          <a:chExt cx="0" cy="0"/>
+        </a:xfrm>
+      </p:grpSpPr>
+    </p:spTree>
+  </p:cSld>
+  <mc:AlternateContent>
+    <mc:Choice Requires="p14">
+      <p:transition spd="slow" p14:dur="2000"/>
+    </mc:Choice>
+    <mc:Fallback>
+      <p:transition spd="slow"/>
+    </mc:Fallback>
+  </mc:AlternateContent>
+</p:sld>
+</file>
+
+<file path=ppt/slides/slide6.xml><?xml version="1.0" encoding="utf-8"?>
+<p:sld xmlns:a="http://schemas.openxmlformats.org/drawingml/2006/main" xmlns:p="http://schemas.openxmlformats.org/presentationml/2006/main" xmlns:r="http://schemas.openxmlformats.org/officeDocument/2006/relationships" xmlns:p14="http://schemas.microsoft.com/office/powerpoint/2010/main" xmlns:p15="http://schemas.microsoft.com/office/powerpoint/2012/main" xmlns:mc="http://schemas.openxmlformats.org/markup-compatibility/2006">
+  <p:cSld>
+    <p:bg>
+      <p:bgPr>
+        <a:gradFill rotWithShape="0">
+          <a:gsLst>
+            <a:gs pos="0">
+              <a:srgbClr val="729FCF"/>
+            </a:gs>
+            <a:gs pos="100000">
+              <a:srgbClr val="000000"/>
+            </a:gs>
+          </a:gsLst>
+          <a:path path="circle">
+            <a:fillToRect l="50000" t="50000" r="50000" b="50000"/>
+          </a:path>
+        </a:gradFill>
+      </p:bgPr>
+    </p:bg>
+    <p:spTree>
+      <p:nvGrpSpPr>
+        <p:cNvPr id="1" name=""/>
+        <p:cNvGrpSpPr/>
+        <p:nvPr/>
+      </p:nvGrpSpPr>
+      <p:grpSpPr>
+        <a:xfrm>
+          <a:off x="0" y="0"/>
+          <a:ext cx="0" cy="0"/>
+          <a:chOff x="0" y="0"/>
+          <a:chExt cx="0" cy="0"/>
+        </a:xfrm>
+      </p:grpSpPr>
+    </p:spTree>
+  </p:cSld>
+  <mc:AlternateContent>
+    <mc:Choice Requires="p14">
+      <p:transition spd="slow" p14:dur="2000"/>
+    </mc:Choice>
+    <mc:Fallback>
+      <p:transition spd="slow"/>
+    </mc:Fallback>
+  </mc:AlternateContent>
+</p:sld>
+</file>
+
+<file path=ppt/slides/slide7.xml><?xml version="1.0" encoding="utf-8"?>
 <p:sld xmlns:a="http://schemas.openxmlformats.org/drawingml/2006/main" xmlns:p="http://schemas.openxmlformats.org/presentationml/2006/main" xmlns:r="http://schemas.openxmlformats.org/officeDocument/2006/relationships" xmlns:p14="http://schemas.microsoft.com/office/powerpoint/2010/main" xmlns:p15="http://schemas.microsoft.com/office/powerpoint/2012/main" xmlns:mc="http://schemas.openxmlformats.org/markup-compatibility/2006">
   <p:cSld>
     <p:spTree>

</xml_diff>

<commit_message>
Circular progress by loading animation from server added.
</commit_message>
<xml_diff>
--- a/docs/Stock-Exchange-Sim.pptx
+++ b/docs/Stock-Exchange-Sim.pptx
@@ -12,6 +12,8 @@
     <p:sldId id="260" r:id="rId7"/>
     <p:sldId id="261" r:id="rId8"/>
     <p:sldId id="262" r:id="rId9"/>
+    <p:sldId id="263" r:id="rId10"/>
+    <p:sldId id="264" r:id="rId11"/>
   </p:sldIdLst>
   <p:sldSz cx="10080625" cy="5670550"/>
   <p:notesSz cx="7559675" cy="10691813"/>
@@ -48,7 +50,7 @@
         <p:spPr>
           <a:xfrm>
             <a:off x="504000" y="28800"/>
-            <a:ext cx="9071280" cy="1341000"/>
+            <a:ext cx="9070920" cy="1341000"/>
           </a:xfrm>
           <a:prstGeom prst="rect">
             <a:avLst/>
@@ -90,7 +92,7 @@
         <p:spPr>
           <a:xfrm>
             <a:off x="504000" y="2726280"/>
-            <a:ext cx="9071280" cy="488160"/>
+            <a:ext cx="9070920" cy="488160"/>
           </a:xfrm>
           <a:prstGeom prst="rect">
             <a:avLst/>
@@ -153,7 +155,7 @@
         <p:txBody>
           <a:bodyPr/>
           <a:p>
-            <a:fld id="{D45A69AA-359F-4D6E-BAE1-DF082B006ACA}" type="slidenum">
+            <a:fld id="{FB6D755C-F713-4C96-9081-C8D5A7213878}" type="slidenum">
               <a:t>&lt;#&gt;</a:t>
             </a:fld>
           </a:p>
@@ -215,7 +217,7 @@
         <p:spPr>
           <a:xfrm>
             <a:off x="504000" y="28800"/>
-            <a:ext cx="9071280" cy="1341000"/>
+            <a:ext cx="9070920" cy="1341000"/>
           </a:xfrm>
           <a:prstGeom prst="rect">
             <a:avLst/>
@@ -255,7 +257,29 @@
                 <a:uFillTx/>
                 <a:latin typeface="Arial"/>
               </a:rPr>
-              <a:t>Format des Titeltextes durch Klicken bearbeiten</a:t>
+              <a:t>Format des </a:t>
+            </a:r>
+            <a:r>
+              <a:rPr lang="de-DE" sz="4400" b="0" u="none" strike="noStrike">
+                <a:solidFill>
+                  <a:srgbClr val="000000"/>
+                </a:solidFill>
+                <a:effectLst/>
+                <a:uFillTx/>
+                <a:latin typeface="Arial"/>
+              </a:rPr>
+              <a:t>Titeltextes durch </a:t>
+            </a:r>
+            <a:r>
+              <a:rPr lang="de-DE" sz="4400" b="0" u="none" strike="noStrike">
+                <a:solidFill>
+                  <a:srgbClr val="000000"/>
+                </a:solidFill>
+                <a:effectLst/>
+                <a:uFillTx/>
+                <a:latin typeface="Arial"/>
+              </a:rPr>
+              <a:t>Klicken bearbeiten</a:t>
             </a:r>
             <a:endParaRPr lang="de-DE" sz="4400" b="0" u="none" strike="noStrike">
               <a:solidFill>
@@ -281,7 +305,7 @@
         <p:spPr>
           <a:xfrm>
             <a:off x="3447360" y="5165280"/>
-            <a:ext cx="3194640" cy="390240"/>
+            <a:ext cx="3194280" cy="389880"/>
           </a:xfrm>
           <a:prstGeom prst="rect">
             <a:avLst/>
@@ -359,7 +383,7 @@
         <p:spPr>
           <a:xfrm>
             <a:off x="7227360" y="5165280"/>
-            <a:ext cx="2347920" cy="390240"/>
+            <a:ext cx="2347560" cy="389880"/>
           </a:xfrm>
           <a:prstGeom prst="rect">
             <a:avLst/>
@@ -402,7 +426,7 @@
                 <a:tab pos="0" algn="l"/>
               </a:tabLst>
             </a:pPr>
-            <a:fld id="{D785937B-F156-4EB9-B7FA-63F9851AB561}" type="slidenum">
+            <a:fld id="{FA66A602-9324-4377-81C2-F9C0BC81B74B}" type="slidenum">
               <a:rPr lang="de-DE" sz="1400" b="0" u="none" strike="noStrike">
                 <a:solidFill>
                   <a:srgbClr val="000000"/>
@@ -437,7 +461,7 @@
         <p:spPr>
           <a:xfrm>
             <a:off x="504000" y="5165280"/>
-            <a:ext cx="2347920" cy="390240"/>
+            <a:ext cx="2347560" cy="389880"/>
           </a:xfrm>
           <a:prstGeom prst="rect">
             <a:avLst/>
@@ -921,20 +945,16 @@
           <a:chExt cx="0" cy="0"/>
         </a:xfrm>
       </p:grpSpPr>
-      <p:pic>
-        <p:nvPicPr>
+      <p:sp>
+        <p:nvSpPr>
           <p:cNvPr id="9" name=""/>
-          <p:cNvPicPr/>
+          <p:cNvSpPr txBox="1"/>
           <p:nvPr/>
-        </p:nvPicPr>
-        <p:blipFill>
-          <a:blip r:embed="rId1"/>
-          <a:stretch/>
-        </p:blipFill>
+        </p:nvSpPr>
         <p:spPr>
           <a:xfrm>
-            <a:off x="46800" y="180000"/>
-            <a:ext cx="9924840" cy="5334120"/>
+            <a:off x="900000" y="1991520"/>
+            <a:ext cx="8350200" cy="2169720"/>
           </a:xfrm>
           <a:prstGeom prst="rect">
             <a:avLst/>
@@ -944,7 +964,139 @@
             <a:noFill/>
           </a:ln>
         </p:spPr>
-      </p:pic>
+        <p:txBody>
+          <a:bodyPr lIns="90000" tIns="45000" rIns="90000" bIns="45000" anchor="t">
+            <a:spAutoFit/>
+          </a:bodyPr>
+          <a:p>
+            <a:endParaRPr lang="de-DE" sz="1000" b="0" u="none" strike="noStrike">
+              <a:solidFill>
+                <a:srgbClr val="FFFFFF"/>
+              </a:solidFill>
+              <a:effectLst/>
+              <a:uFillTx/>
+              <a:latin typeface="Arial"/>
+            </a:endParaRPr>
+          </a:p>
+          <a:p>
+            <a:r>
+              <a:rPr lang="de-DE" sz="1300" b="0" u="none" strike="noStrike">
+                <a:solidFill>
+                  <a:srgbClr val="FFFFFF"/>
+                </a:solidFill>
+                <a:effectLst/>
+                <a:uFillTx/>
+                <a:latin typeface="Arial"/>
+              </a:rPr>
+              <a:t>Purpose:</a:t>
+            </a:r>
+            <a:endParaRPr lang="de-DE" sz="1300" b="0" u="none" strike="noStrike">
+              <a:solidFill>
+                <a:srgbClr val="FFFFFF"/>
+              </a:solidFill>
+              <a:effectLst/>
+              <a:uFillTx/>
+              <a:latin typeface="Arial"/>
+            </a:endParaRPr>
+          </a:p>
+          <a:p>
+            <a:r>
+              <a:rPr lang="de-DE" sz="1300" b="0" u="none" strike="noStrike">
+                <a:solidFill>
+                  <a:srgbClr val="FFFFFF"/>
+                </a:solidFill>
+                <a:effectLst/>
+                <a:uFillTx/>
+                <a:latin typeface="Arial"/>
+              </a:rPr>
+              <a:t>React web application for a stock market simulation. Users can browse available stocks, buy and sell positions, track portfolio value, simulate price changes over days, and review budget development with charted cash, portfolio, and total value lines.</a:t>
+            </a:r>
+            <a:endParaRPr lang="de-DE" sz="1300" b="0" u="none" strike="noStrike">
+              <a:solidFill>
+                <a:srgbClr val="FFFFFF"/>
+              </a:solidFill>
+              <a:effectLst/>
+              <a:uFillTx/>
+              <a:latin typeface="Arial"/>
+            </a:endParaRPr>
+          </a:p>
+          <a:p>
+            <a:r>
+              <a:rPr lang="de-DE" sz="1300" b="0" u="none" strike="noStrike">
+                <a:solidFill>
+                  <a:srgbClr val="FFFFFF"/>
+                </a:solidFill>
+                <a:effectLst/>
+                <a:uFillTx/>
+                <a:latin typeface="Arial"/>
+              </a:rPr>
+              <a:t>The app is built with Vite, React, React Router, Material UI, and Axios. It expects a JSON API backend with `companies` and `stocks` resources. </a:t>
+            </a:r>
+            <a:endParaRPr lang="de-DE" sz="1300" b="0" u="none" strike="noStrike">
+              <a:solidFill>
+                <a:srgbClr val="FFFFFF"/>
+              </a:solidFill>
+              <a:effectLst/>
+              <a:uFillTx/>
+              <a:latin typeface="Arial"/>
+            </a:endParaRPr>
+          </a:p>
+        </p:txBody>
+      </p:sp>
+      <p:sp>
+        <p:nvSpPr>
+          <p:cNvPr id="10" name=""/>
+          <p:cNvSpPr txBox="1"/>
+          <p:nvPr/>
+        </p:nvSpPr>
+        <p:spPr>
+          <a:xfrm>
+            <a:off x="1440000" y="396000"/>
+            <a:ext cx="7270200" cy="402840"/>
+          </a:xfrm>
+          <a:prstGeom prst="rect">
+            <a:avLst/>
+          </a:prstGeom>
+          <a:noFill/>
+          <a:ln w="0">
+            <a:noFill/>
+          </a:ln>
+        </p:spPr>
+        <p:txBody>
+          <a:bodyPr lIns="90000" tIns="45000" rIns="90000" bIns="45000" anchor="t" anchorCtr="1">
+            <a:spAutoFit/>
+          </a:bodyPr>
+          <a:p>
+            <a:pPr algn="ctr">
+              <a:spcBef>
+                <a:spcPts val="1191"/>
+              </a:spcBef>
+              <a:spcAft>
+                <a:spcPts val="992"/>
+              </a:spcAft>
+            </a:pPr>
+            <a:r>
+              <a:rPr lang="de-DE" sz="2200" b="0" u="none" strike="noStrike">
+                <a:solidFill>
+                  <a:srgbClr val="FFFFFF"/>
+                </a:solidFill>
+                <a:effectLst/>
+                <a:uFillTx/>
+                <a:latin typeface="Arial"/>
+              </a:rPr>
+              <a:t>Stock Exchange Simulation Application</a:t>
+            </a:r>
+            <a:endParaRPr lang="de-DE" sz="2200" b="0" u="none" strike="noStrike">
+              <a:solidFill>
+                <a:srgbClr val="FFFFFF"/>
+              </a:solidFill>
+              <a:effectLst/>
+              <a:uFillTx/>
+              <a:latin typeface="Arial"/>
+            </a:endParaRPr>
+          </a:p>
+        </p:txBody>
+      </p:sp>
     </p:spTree>
   </p:cSld>
   <mc:AlternateContent>
@@ -992,20 +1144,16 @@
           <a:chExt cx="0" cy="0"/>
         </a:xfrm>
       </p:grpSpPr>
-      <p:pic>
-        <p:nvPicPr>
-          <p:cNvPr id="10" name=""/>
-          <p:cNvPicPr/>
+      <p:sp>
+        <p:nvSpPr>
+          <p:cNvPr id="11" name=""/>
+          <p:cNvSpPr txBox="1"/>
           <p:nvPr/>
-        </p:nvPicPr>
-        <p:blipFill>
-          <a:blip r:embed="rId1"/>
-          <a:stretch/>
-        </p:blipFill>
+        </p:nvSpPr>
         <p:spPr>
           <a:xfrm>
-            <a:off x="82800" y="150840"/>
-            <a:ext cx="9899640" cy="5320800"/>
+            <a:off x="900000" y="1955520"/>
+            <a:ext cx="8350200" cy="2954520"/>
           </a:xfrm>
           <a:prstGeom prst="rect">
             <a:avLst/>
@@ -1015,7 +1163,296 @@
             <a:noFill/>
           </a:ln>
         </p:spPr>
-      </p:pic>
+        <p:txBody>
+          <a:bodyPr lIns="90000" tIns="45000" rIns="90000" bIns="45000" anchor="t">
+            <a:spAutoFit/>
+          </a:bodyPr>
+          <a:p>
+            <a:r>
+              <a:rPr lang="de-DE" sz="1400" b="0" u="none" strike="noStrike">
+                <a:solidFill>
+                  <a:srgbClr val="FFFFFF"/>
+                </a:solidFill>
+                <a:effectLst/>
+                <a:uFillTx/>
+                <a:latin typeface="Arial"/>
+              </a:rPr>
+              <a:t>Features:</a:t>
+            </a:r>
+            <a:endParaRPr lang="de-DE" sz="1400" b="0" u="none" strike="noStrike">
+              <a:solidFill>
+                <a:srgbClr val="FFFFFF"/>
+              </a:solidFill>
+              <a:effectLst/>
+              <a:uFillTx/>
+              <a:latin typeface="Arial"/>
+            </a:endParaRPr>
+          </a:p>
+          <a:p>
+            <a:r>
+              <a:rPr lang="de-DE" sz="1400" b="0" u="none" strike="noStrike">
+                <a:solidFill>
+                  <a:srgbClr val="FFFFFF"/>
+                </a:solidFill>
+                <a:effectLst/>
+                <a:uFillTx/>
+                <a:latin typeface="Arial"/>
+              </a:rPr>
+              <a:t>- Market overview with searchable stock list</a:t>
+            </a:r>
+            <a:endParaRPr lang="de-DE" sz="1400" b="0" u="none" strike="noStrike">
+              <a:solidFill>
+                <a:srgbClr val="FFFFFF"/>
+              </a:solidFill>
+              <a:effectLst/>
+              <a:uFillTx/>
+              <a:latin typeface="Arial"/>
+            </a:endParaRPr>
+          </a:p>
+          <a:p>
+            <a:r>
+              <a:rPr lang="de-DE" sz="1400" b="0" u="none" strike="noStrike">
+                <a:solidFill>
+                  <a:srgbClr val="FFFFFF"/>
+                </a:solidFill>
+                <a:effectLst/>
+                <a:uFillTx/>
+                <a:latin typeface="Arial"/>
+              </a:rPr>
+              <a:t>- Add, edit, and delete stock/company data</a:t>
+            </a:r>
+            <a:endParaRPr lang="de-DE" sz="1400" b="0" u="none" strike="noStrike">
+              <a:solidFill>
+                <a:srgbClr val="FFFFFF"/>
+              </a:solidFill>
+              <a:effectLst/>
+              <a:uFillTx/>
+              <a:latin typeface="Arial"/>
+            </a:endParaRPr>
+          </a:p>
+          <a:p>
+            <a:r>
+              <a:rPr lang="de-DE" sz="1400" b="0" u="none" strike="noStrike">
+                <a:solidFill>
+                  <a:srgbClr val="FFFFFF"/>
+                </a:solidFill>
+                <a:effectLst/>
+                <a:uFillTx/>
+                <a:latin typeface="Arial"/>
+              </a:rPr>
+              <a:t>- Buy and sell shares from a stock detail page</a:t>
+            </a:r>
+            <a:endParaRPr lang="de-DE" sz="1400" b="0" u="none" strike="noStrike">
+              <a:solidFill>
+                <a:srgbClr val="FFFFFF"/>
+              </a:solidFill>
+              <a:effectLst/>
+              <a:uFillTx/>
+              <a:latin typeface="Arial"/>
+            </a:endParaRPr>
+          </a:p>
+          <a:p>
+            <a:r>
+              <a:rPr lang="de-DE" sz="1400" b="0" u="none" strike="noStrike">
+                <a:solidFill>
+                  <a:srgbClr val="FFFFFF"/>
+                </a:solidFill>
+                <a:effectLst/>
+                <a:uFillTx/>
+                <a:latin typeface="Arial"/>
+              </a:rPr>
+              <a:t>- Portfolio page with current holdings and gains/losses</a:t>
+            </a:r>
+            <a:endParaRPr lang="de-DE" sz="1400" b="0" u="none" strike="noStrike">
+              <a:solidFill>
+                <a:srgbClr val="FFFFFF"/>
+              </a:solidFill>
+              <a:effectLst/>
+              <a:uFillTx/>
+              <a:latin typeface="Arial"/>
+            </a:endParaRPr>
+          </a:p>
+          <a:p>
+            <a:r>
+              <a:rPr lang="de-DE" sz="1400" b="0" u="none" strike="noStrike">
+                <a:solidFill>
+                  <a:srgbClr val="FFFFFF"/>
+                </a:solidFill>
+                <a:effectLst/>
+                <a:uFillTx/>
+                <a:latin typeface="Arial"/>
+              </a:rPr>
+              <a:t>- Budget page with daily value development chart</a:t>
+            </a:r>
+            <a:endParaRPr lang="de-DE" sz="1400" b="0" u="none" strike="noStrike">
+              <a:solidFill>
+                <a:srgbClr val="FFFFFF"/>
+              </a:solidFill>
+              <a:effectLst/>
+              <a:uFillTx/>
+              <a:latin typeface="Arial"/>
+            </a:endParaRPr>
+          </a:p>
+          <a:p>
+            <a:r>
+              <a:rPr lang="de-DE" sz="1400" b="0" u="none" strike="noStrike">
+                <a:solidFill>
+                  <a:srgbClr val="FFFFFF"/>
+                </a:solidFill>
+                <a:effectLst/>
+                <a:uFillTx/>
+                <a:latin typeface="Arial"/>
+              </a:rPr>
+              <a:t>- Toggle chart lines for cash, portfolio value, and total value</a:t>
+            </a:r>
+            <a:endParaRPr lang="de-DE" sz="1400" b="0" u="none" strike="noStrike">
+              <a:solidFill>
+                <a:srgbClr val="FFFFFF"/>
+              </a:solidFill>
+              <a:effectLst/>
+              <a:uFillTx/>
+              <a:latin typeface="Arial"/>
+            </a:endParaRPr>
+          </a:p>
+          <a:p>
+            <a:r>
+              <a:rPr lang="de-DE" sz="1400" b="0" u="none" strike="noStrike">
+                <a:solidFill>
+                  <a:srgbClr val="FFFFFF"/>
+                </a:solidFill>
+                <a:effectLst/>
+                <a:uFillTx/>
+                <a:latin typeface="Arial"/>
+              </a:rPr>
+              <a:t>- Simulation day button that changes stock prices and stores daily budget snapshots</a:t>
+            </a:r>
+            <a:endParaRPr lang="de-DE" sz="1400" b="0" u="none" strike="noStrike">
+              <a:solidFill>
+                <a:srgbClr val="FFFFFF"/>
+              </a:solidFill>
+              <a:effectLst/>
+              <a:uFillTx/>
+              <a:latin typeface="Arial"/>
+            </a:endParaRPr>
+          </a:p>
+          <a:p>
+            <a:r>
+              <a:rPr lang="de-DE" sz="1400" b="0" u="none" strike="noStrike">
+                <a:solidFill>
+                  <a:srgbClr val="FFFFFF"/>
+                </a:solidFill>
+                <a:effectLst/>
+                <a:uFillTx/>
+                <a:latin typeface="Arial"/>
+              </a:rPr>
+              <a:t>- Local persistence for transactions, day counter, budget history, and chart visibility</a:t>
+            </a:r>
+            <a:endParaRPr lang="de-DE" sz="1400" b="0" u="none" strike="noStrike">
+              <a:solidFill>
+                <a:srgbClr val="FFFFFF"/>
+              </a:solidFill>
+              <a:effectLst/>
+              <a:uFillTx/>
+              <a:latin typeface="Arial"/>
+            </a:endParaRPr>
+          </a:p>
+          <a:p>
+            <a:r>
+              <a:rPr lang="de-DE" sz="1400" b="0" u="none" strike="noStrike">
+                <a:solidFill>
+                  <a:srgbClr val="FFFFFF"/>
+                </a:solidFill>
+                <a:effectLst/>
+                <a:uFillTx/>
+                <a:latin typeface="Arial"/>
+              </a:rPr>
+              <a:t>- Vercel-compatible single page app routing</a:t>
+            </a:r>
+            <a:endParaRPr lang="de-DE" sz="1400" b="0" u="none" strike="noStrike">
+              <a:solidFill>
+                <a:srgbClr val="FFFFFF"/>
+              </a:solidFill>
+              <a:effectLst/>
+              <a:uFillTx/>
+              <a:latin typeface="Arial"/>
+            </a:endParaRPr>
+          </a:p>
+          <a:p>
+            <a:endParaRPr lang="de-DE" sz="1000" b="0" u="none" strike="noStrike">
+              <a:solidFill>
+                <a:srgbClr val="FFFFFF"/>
+              </a:solidFill>
+              <a:effectLst/>
+              <a:uFillTx/>
+              <a:latin typeface="Arial"/>
+            </a:endParaRPr>
+          </a:p>
+          <a:p>
+            <a:endParaRPr lang="de-DE" sz="1300" b="0" u="none" strike="noStrike">
+              <a:solidFill>
+                <a:srgbClr val="FFFFFF"/>
+              </a:solidFill>
+              <a:effectLst/>
+              <a:uFillTx/>
+              <a:latin typeface="Arial"/>
+            </a:endParaRPr>
+          </a:p>
+        </p:txBody>
+      </p:sp>
+      <p:sp>
+        <p:nvSpPr>
+          <p:cNvPr id="12" name=""/>
+          <p:cNvSpPr txBox="1"/>
+          <p:nvPr/>
+        </p:nvSpPr>
+        <p:spPr>
+          <a:xfrm>
+            <a:off x="1440000" y="396000"/>
+            <a:ext cx="7270200" cy="402840"/>
+          </a:xfrm>
+          <a:prstGeom prst="rect">
+            <a:avLst/>
+          </a:prstGeom>
+          <a:noFill/>
+          <a:ln w="0">
+            <a:noFill/>
+          </a:ln>
+        </p:spPr>
+        <p:txBody>
+          <a:bodyPr lIns="90000" tIns="45000" rIns="90000" bIns="45000" anchor="t" anchorCtr="1">
+            <a:spAutoFit/>
+          </a:bodyPr>
+          <a:p>
+            <a:pPr algn="ctr">
+              <a:spcBef>
+                <a:spcPts val="1191"/>
+              </a:spcBef>
+              <a:spcAft>
+                <a:spcPts val="992"/>
+              </a:spcAft>
+            </a:pPr>
+            <a:r>
+              <a:rPr lang="de-DE" sz="2200" b="0" u="none" strike="noStrike">
+                <a:solidFill>
+                  <a:srgbClr val="FFFFFF"/>
+                </a:solidFill>
+                <a:effectLst/>
+                <a:uFillTx/>
+                <a:latin typeface="Arial"/>
+              </a:rPr>
+              <a:t>Stock Exchange Simulation Application</a:t>
+            </a:r>
+            <a:endParaRPr lang="de-DE" sz="2200" b="0" u="none" strike="noStrike">
+              <a:solidFill>
+                <a:srgbClr val="FFFFFF"/>
+              </a:solidFill>
+              <a:effectLst/>
+              <a:uFillTx/>
+              <a:latin typeface="Arial"/>
+            </a:endParaRPr>
+          </a:p>
+        </p:txBody>
+      </p:sp>
     </p:spTree>
   </p:cSld>
   <mc:AlternateContent>
@@ -1063,20 +1500,16 @@
           <a:chExt cx="0" cy="0"/>
         </a:xfrm>
       </p:grpSpPr>
-      <p:pic>
-        <p:nvPicPr>
-          <p:cNvPr id="11" name=""/>
-          <p:cNvPicPr/>
+      <p:sp>
+        <p:nvSpPr>
+          <p:cNvPr id="13" name=""/>
+          <p:cNvSpPr txBox="1"/>
           <p:nvPr/>
-        </p:nvPicPr>
-        <p:blipFill>
-          <a:blip r:embed="rId1"/>
-          <a:stretch/>
-        </p:blipFill>
+        </p:nvSpPr>
         <p:spPr>
           <a:xfrm>
-            <a:off x="109440" y="180000"/>
-            <a:ext cx="9995400" cy="5372280"/>
+            <a:off x="900000" y="1487520"/>
+            <a:ext cx="8350200" cy="3508920"/>
           </a:xfrm>
           <a:prstGeom prst="rect">
             <a:avLst/>
@@ -1086,7 +1519,254 @@
             <a:noFill/>
           </a:ln>
         </p:spPr>
-      </p:pic>
+        <p:txBody>
+          <a:bodyPr lIns="90000" tIns="45000" rIns="90000" bIns="45000" anchor="t">
+            <a:spAutoFit/>
+          </a:bodyPr>
+          <a:p>
+            <a:r>
+              <a:rPr lang="de-DE" sz="1400" b="0" u="none" strike="noStrike">
+                <a:solidFill>
+                  <a:srgbClr val="FFFFFF"/>
+                </a:solidFill>
+                <a:effectLst/>
+                <a:uFillTx/>
+                <a:latin typeface="Arial"/>
+              </a:rPr>
+              <a:t>Mock JSON Server</a:t>
+            </a:r>
+            <a:endParaRPr lang="de-DE" sz="1400" b="0" u="none" strike="noStrike">
+              <a:solidFill>
+                <a:srgbClr val="FFFFFF"/>
+              </a:solidFill>
+              <a:effectLst/>
+              <a:uFillTx/>
+              <a:latin typeface="Arial"/>
+            </a:endParaRPr>
+          </a:p>
+          <a:p>
+            <a:r>
+              <a:rPr lang="de-DE" sz="1400" b="0" u="none" strike="noStrike">
+                <a:solidFill>
+                  <a:srgbClr val="FFFFFF"/>
+                </a:solidFill>
+                <a:effectLst/>
+                <a:uFillTx/>
+                <a:latin typeface="Arial"/>
+              </a:rPr>
+              <a:t>This is the mock backend for the stock exchange simulator. It uses`json-server` to expose the data in `db.json` as a REST API, so the React client can load, create, update, and delete project data without a real database.</a:t>
+            </a:r>
+            <a:endParaRPr lang="de-DE" sz="1400" b="0" u="none" strike="noStrike">
+              <a:solidFill>
+                <a:srgbClr val="FFFFFF"/>
+              </a:solidFill>
+              <a:effectLst/>
+              <a:uFillTx/>
+              <a:latin typeface="Arial"/>
+            </a:endParaRPr>
+          </a:p>
+          <a:p>
+            <a:r>
+              <a:rPr lang="de-DE" sz="1400" b="0" u="none" strike="noStrike">
+                <a:solidFill>
+                  <a:srgbClr val="FFFFFF"/>
+                </a:solidFill>
+                <a:effectLst/>
+                <a:uFillTx/>
+                <a:latin typeface="Arial"/>
+              </a:rPr>
+              <a:t>The mock server provides the app data during development:</a:t>
+            </a:r>
+            <a:endParaRPr lang="de-DE" sz="1400" b="0" u="none" strike="noStrike">
+              <a:solidFill>
+                <a:srgbClr val="FFFFFF"/>
+              </a:solidFill>
+              <a:effectLst/>
+              <a:uFillTx/>
+              <a:latin typeface="Arial"/>
+            </a:endParaRPr>
+          </a:p>
+          <a:p>
+            <a:r>
+              <a:rPr lang="de-DE" sz="1400" b="0" u="none" strike="noStrike">
+                <a:solidFill>
+                  <a:srgbClr val="FFFFFF"/>
+                </a:solidFill>
+                <a:effectLst/>
+                <a:uFillTx/>
+                <a:latin typeface="Arial"/>
+              </a:rPr>
+              <a:t>- companies and their profile information</a:t>
+            </a:r>
+            <a:endParaRPr lang="de-DE" sz="1400" b="0" u="none" strike="noStrike">
+              <a:solidFill>
+                <a:srgbClr val="FFFFFF"/>
+              </a:solidFill>
+              <a:effectLst/>
+              <a:uFillTx/>
+              <a:latin typeface="Arial"/>
+            </a:endParaRPr>
+          </a:p>
+          <a:p>
+            <a:r>
+              <a:rPr lang="de-DE" sz="1400" b="0" u="none" strike="noStrike">
+                <a:solidFill>
+                  <a:srgbClr val="FFFFFF"/>
+                </a:solidFill>
+                <a:effectLst/>
+                <a:uFillTx/>
+                <a:latin typeface="Arial"/>
+              </a:rPr>
+              <a:t>- stocks and their current prices</a:t>
+            </a:r>
+            <a:endParaRPr lang="de-DE" sz="1400" b="0" u="none" strike="noStrike">
+              <a:solidFill>
+                <a:srgbClr val="FFFFFF"/>
+              </a:solidFill>
+              <a:effectLst/>
+              <a:uFillTx/>
+              <a:latin typeface="Arial"/>
+            </a:endParaRPr>
+          </a:p>
+          <a:p>
+            <a:r>
+              <a:rPr lang="de-DE" sz="1400" b="0" u="none" strike="noStrike">
+                <a:solidFill>
+                  <a:srgbClr val="FFFFFF"/>
+                </a:solidFill>
+                <a:effectLst/>
+                <a:uFillTx/>
+                <a:latin typeface="Arial"/>
+              </a:rPr>
+              <a:t>- certificates and bonds</a:t>
+            </a:r>
+            <a:endParaRPr lang="de-DE" sz="1400" b="0" u="none" strike="noStrike">
+              <a:solidFill>
+                <a:srgbClr val="FFFFFF"/>
+              </a:solidFill>
+              <a:effectLst/>
+              <a:uFillTx/>
+              <a:latin typeface="Arial"/>
+            </a:endParaRPr>
+          </a:p>
+          <a:p>
+            <a:r>
+              <a:rPr lang="de-DE" sz="1400" b="0" u="none" strike="noStrike">
+                <a:solidFill>
+                  <a:srgbClr val="FFFFFF"/>
+                </a:solidFill>
+                <a:effectLst/>
+                <a:uFillTx/>
+                <a:latin typeface="Arial"/>
+              </a:rPr>
+              <a:t>- example transactions</a:t>
+            </a:r>
+            <a:endParaRPr lang="de-DE" sz="1400" b="0" u="none" strike="noStrike">
+              <a:solidFill>
+                <a:srgbClr val="FFFFFF"/>
+              </a:solidFill>
+              <a:effectLst/>
+              <a:uFillTx/>
+              <a:latin typeface="Arial"/>
+            </a:endParaRPr>
+          </a:p>
+          <a:p>
+            <a:r>
+              <a:rPr lang="de-DE" sz="1400" b="0" u="none" strike="noStrike">
+                <a:solidFill>
+                  <a:srgbClr val="FFFFFF"/>
+                </a:solidFill>
+                <a:effectLst/>
+                <a:uFillTx/>
+                <a:latin typeface="Arial"/>
+              </a:rPr>
+              <a:t>- logo/image assets from the `assets` folder </a:t>
+            </a:r>
+            <a:endParaRPr lang="de-DE" sz="1400" b="0" u="none" strike="noStrike">
+              <a:solidFill>
+                <a:srgbClr val="FFFFFF"/>
+              </a:solidFill>
+              <a:effectLst/>
+              <a:uFillTx/>
+              <a:latin typeface="Arial"/>
+            </a:endParaRPr>
+          </a:p>
+          <a:p>
+            <a:endParaRPr lang="de-DE" sz="1000" b="0" u="none" strike="noStrike">
+              <a:solidFill>
+                <a:srgbClr val="FFFFFF"/>
+              </a:solidFill>
+              <a:effectLst/>
+              <a:uFillTx/>
+              <a:latin typeface="Arial"/>
+            </a:endParaRPr>
+          </a:p>
+          <a:p>
+            <a:endParaRPr lang="de-DE" sz="1300" b="0" u="none" strike="noStrike">
+              <a:solidFill>
+                <a:srgbClr val="FFFFFF"/>
+              </a:solidFill>
+              <a:effectLst/>
+              <a:uFillTx/>
+              <a:latin typeface="Arial"/>
+            </a:endParaRPr>
+          </a:p>
+        </p:txBody>
+      </p:sp>
+      <p:sp>
+        <p:nvSpPr>
+          <p:cNvPr id="14" name=""/>
+          <p:cNvSpPr txBox="1"/>
+          <p:nvPr/>
+        </p:nvSpPr>
+        <p:spPr>
+          <a:xfrm>
+            <a:off x="1440000" y="396000"/>
+            <a:ext cx="7270200" cy="402840"/>
+          </a:xfrm>
+          <a:prstGeom prst="rect">
+            <a:avLst/>
+          </a:prstGeom>
+          <a:noFill/>
+          <a:ln w="0">
+            <a:noFill/>
+          </a:ln>
+        </p:spPr>
+        <p:txBody>
+          <a:bodyPr lIns="90000" tIns="45000" rIns="90000" bIns="45000" anchor="t" anchorCtr="1">
+            <a:spAutoFit/>
+          </a:bodyPr>
+          <a:p>
+            <a:pPr algn="ctr">
+              <a:spcBef>
+                <a:spcPts val="1191"/>
+              </a:spcBef>
+              <a:spcAft>
+                <a:spcPts val="992"/>
+              </a:spcAft>
+            </a:pPr>
+            <a:r>
+              <a:rPr lang="de-DE" sz="2200" b="0" u="none" strike="noStrike">
+                <a:solidFill>
+                  <a:srgbClr val="FFFFFF"/>
+                </a:solidFill>
+                <a:effectLst/>
+                <a:uFillTx/>
+                <a:latin typeface="Arial"/>
+              </a:rPr>
+              <a:t>Stock Exchange Simulation Application</a:t>
+            </a:r>
+            <a:endParaRPr lang="de-DE" sz="2200" b="0" u="none" strike="noStrike">
+              <a:solidFill>
+                <a:srgbClr val="FFFFFF"/>
+              </a:solidFill>
+              <a:effectLst/>
+              <a:uFillTx/>
+              <a:latin typeface="Arial"/>
+            </a:endParaRPr>
+          </a:p>
+        </p:txBody>
+      </p:sp>
     </p:spTree>
   </p:cSld>
   <mc:AlternateContent>
@@ -1136,7 +1816,7 @@
       </p:grpSpPr>
       <p:pic>
         <p:nvPicPr>
-          <p:cNvPr id="12" name=""/>
+          <p:cNvPr id="15" name=""/>
           <p:cNvPicPr/>
           <p:nvPr/>
         </p:nvPicPr>
@@ -1146,8 +1826,8 @@
         </p:blipFill>
         <p:spPr>
           <a:xfrm>
-            <a:off x="37440" y="144000"/>
-            <a:ext cx="9995400" cy="5372280"/>
+            <a:off x="46800" y="180000"/>
+            <a:ext cx="9924480" cy="5333760"/>
           </a:xfrm>
           <a:prstGeom prst="rect">
             <a:avLst/>
@@ -1205,6 +1885,30 @@
           <a:chExt cx="0" cy="0"/>
         </a:xfrm>
       </p:grpSpPr>
+      <p:pic>
+        <p:nvPicPr>
+          <p:cNvPr id="16" name=""/>
+          <p:cNvPicPr/>
+          <p:nvPr/>
+        </p:nvPicPr>
+        <p:blipFill>
+          <a:blip r:embed="rId1"/>
+          <a:stretch/>
+        </p:blipFill>
+        <p:spPr>
+          <a:xfrm>
+            <a:off x="82800" y="150840"/>
+            <a:ext cx="9899280" cy="5320440"/>
+          </a:xfrm>
+          <a:prstGeom prst="rect">
+            <a:avLst/>
+          </a:prstGeom>
+          <a:noFill/>
+          <a:ln w="0">
+            <a:noFill/>
+          </a:ln>
+        </p:spPr>
+      </p:pic>
     </p:spTree>
   </p:cSld>
   <mc:AlternateContent>
@@ -1252,6 +1956,30 @@
           <a:chExt cx="0" cy="0"/>
         </a:xfrm>
       </p:grpSpPr>
+      <p:pic>
+        <p:nvPicPr>
+          <p:cNvPr id="17" name=""/>
+          <p:cNvPicPr/>
+          <p:nvPr/>
+        </p:nvPicPr>
+        <p:blipFill>
+          <a:blip r:embed="rId1"/>
+          <a:stretch/>
+        </p:blipFill>
+        <p:spPr>
+          <a:xfrm>
+            <a:off x="109440" y="180000"/>
+            <a:ext cx="9995040" cy="5371920"/>
+          </a:xfrm>
+          <a:prstGeom prst="rect">
+            <a:avLst/>
+          </a:prstGeom>
+          <a:noFill/>
+          <a:ln w="0">
+            <a:noFill/>
+          </a:ln>
+        </p:spPr>
+      </p:pic>
     </p:spTree>
   </p:cSld>
   <mc:AlternateContent>
@@ -1268,6 +1996,278 @@
 <file path=ppt/slides/slide7.xml><?xml version="1.0" encoding="utf-8"?>
 <p:sld xmlns:a="http://schemas.openxmlformats.org/drawingml/2006/main" xmlns:p="http://schemas.openxmlformats.org/presentationml/2006/main" xmlns:r="http://schemas.openxmlformats.org/officeDocument/2006/relationships" xmlns:p14="http://schemas.microsoft.com/office/powerpoint/2010/main" xmlns:p15="http://schemas.microsoft.com/office/powerpoint/2012/main" xmlns:mc="http://schemas.openxmlformats.org/markup-compatibility/2006">
   <p:cSld>
+    <p:bg>
+      <p:bgPr>
+        <a:gradFill rotWithShape="0">
+          <a:gsLst>
+            <a:gs pos="0">
+              <a:srgbClr val="729FCF"/>
+            </a:gs>
+            <a:gs pos="100000">
+              <a:srgbClr val="000000"/>
+            </a:gs>
+          </a:gsLst>
+          <a:path path="circle">
+            <a:fillToRect l="50000" t="50000" r="50000" b="50000"/>
+          </a:path>
+        </a:gradFill>
+      </p:bgPr>
+    </p:bg>
+    <p:spTree>
+      <p:nvGrpSpPr>
+        <p:cNvPr id="1" name=""/>
+        <p:cNvGrpSpPr/>
+        <p:nvPr/>
+      </p:nvGrpSpPr>
+      <p:grpSpPr>
+        <a:xfrm>
+          <a:off x="0" y="0"/>
+          <a:ext cx="0" cy="0"/>
+          <a:chOff x="0" y="0"/>
+          <a:chExt cx="0" cy="0"/>
+        </a:xfrm>
+      </p:grpSpPr>
+      <p:pic>
+        <p:nvPicPr>
+          <p:cNvPr id="18" name=""/>
+          <p:cNvPicPr/>
+          <p:nvPr/>
+        </p:nvPicPr>
+        <p:blipFill>
+          <a:blip r:embed="rId1"/>
+          <a:stretch/>
+        </p:blipFill>
+        <p:spPr>
+          <a:xfrm>
+            <a:off x="37440" y="144000"/>
+            <a:ext cx="9995040" cy="5371920"/>
+          </a:xfrm>
+          <a:prstGeom prst="rect">
+            <a:avLst/>
+          </a:prstGeom>
+          <a:noFill/>
+          <a:ln w="0">
+            <a:noFill/>
+          </a:ln>
+        </p:spPr>
+      </p:pic>
+    </p:spTree>
+  </p:cSld>
+  <mc:AlternateContent>
+    <mc:Choice Requires="p14">
+      <p:transition spd="slow" p14:dur="2000"/>
+    </mc:Choice>
+    <mc:Fallback>
+      <p:transition spd="slow"/>
+    </mc:Fallback>
+  </mc:AlternateContent>
+</p:sld>
+</file>
+
+<file path=ppt/slides/slide8.xml><?xml version="1.0" encoding="utf-8"?>
+<p:sld xmlns:a="http://schemas.openxmlformats.org/drawingml/2006/main" xmlns:p="http://schemas.openxmlformats.org/presentationml/2006/main" xmlns:r="http://schemas.openxmlformats.org/officeDocument/2006/relationships" xmlns:p14="http://schemas.microsoft.com/office/powerpoint/2010/main" xmlns:p15="http://schemas.microsoft.com/office/powerpoint/2012/main" xmlns:mc="http://schemas.openxmlformats.org/markup-compatibility/2006">
+  <p:cSld>
+    <p:bg>
+      <p:bgPr>
+        <a:gradFill rotWithShape="0">
+          <a:gsLst>
+            <a:gs pos="0">
+              <a:srgbClr val="729FCF"/>
+            </a:gs>
+            <a:gs pos="100000">
+              <a:srgbClr val="000000"/>
+            </a:gs>
+          </a:gsLst>
+          <a:path path="circle">
+            <a:fillToRect l="50000" t="50000" r="50000" b="50000"/>
+          </a:path>
+        </a:gradFill>
+      </p:bgPr>
+    </p:bg>
+    <p:spTree>
+      <p:nvGrpSpPr>
+        <p:cNvPr id="1" name=""/>
+        <p:cNvGrpSpPr/>
+        <p:nvPr/>
+      </p:nvGrpSpPr>
+      <p:grpSpPr>
+        <a:xfrm>
+          <a:off x="0" y="0"/>
+          <a:ext cx="0" cy="0"/>
+          <a:chOff x="0" y="0"/>
+          <a:chExt cx="0" cy="0"/>
+        </a:xfrm>
+      </p:grpSpPr>
+      <p:sp>
+        <p:nvSpPr>
+          <p:cNvPr id="19" name=""/>
+          <p:cNvSpPr txBox="1"/>
+          <p:nvPr/>
+        </p:nvSpPr>
+        <p:spPr>
+          <a:xfrm>
+            <a:off x="1440360" y="396360"/>
+            <a:ext cx="7270200" cy="2761560"/>
+          </a:xfrm>
+          <a:prstGeom prst="rect">
+            <a:avLst/>
+          </a:prstGeom>
+          <a:noFill/>
+          <a:ln w="0">
+            <a:noFill/>
+          </a:ln>
+        </p:spPr>
+        <p:txBody>
+          <a:bodyPr lIns="90000" tIns="45000" rIns="90000" bIns="45000" anchor="t" anchorCtr="1">
+            <a:spAutoFit/>
+          </a:bodyPr>
+          <a:p>
+            <a:pPr algn="ctr">
+              <a:spcBef>
+                <a:spcPts val="1191"/>
+              </a:spcBef>
+              <a:spcAft>
+                <a:spcPts val="992"/>
+              </a:spcAft>
+            </a:pPr>
+            <a:r>
+              <a:rPr lang="de-DE" sz="2200" b="0" u="none" strike="noStrike">
+                <a:solidFill>
+                  <a:srgbClr val="FFFFFF"/>
+                </a:solidFill>
+                <a:effectLst/>
+                <a:uFillTx/>
+                <a:latin typeface="Arial"/>
+              </a:rPr>
+              <a:t>Stock Exchange Simulation Application</a:t>
+            </a:r>
+            <a:endParaRPr lang="de-DE" sz="2200" b="0" u="none" strike="noStrike">
+              <a:solidFill>
+                <a:srgbClr val="FFFFFF"/>
+              </a:solidFill>
+              <a:effectLst/>
+              <a:uFillTx/>
+              <a:latin typeface="Arial"/>
+            </a:endParaRPr>
+          </a:p>
+          <a:p>
+            <a:pPr algn="ctr">
+              <a:spcBef>
+                <a:spcPts val="1191"/>
+              </a:spcBef>
+              <a:spcAft>
+                <a:spcPts val="992"/>
+              </a:spcAft>
+            </a:pPr>
+            <a:endParaRPr lang="de-DE" sz="2200" b="0" u="none" strike="noStrike">
+              <a:solidFill>
+                <a:srgbClr val="FFFFFF"/>
+              </a:solidFill>
+              <a:effectLst/>
+              <a:uFillTx/>
+              <a:latin typeface="Arial"/>
+            </a:endParaRPr>
+          </a:p>
+          <a:p>
+            <a:pPr algn="ctr">
+              <a:spcBef>
+                <a:spcPts val="1191"/>
+              </a:spcBef>
+              <a:spcAft>
+                <a:spcPts val="992"/>
+              </a:spcAft>
+            </a:pPr>
+            <a:endParaRPr lang="de-DE" sz="2200" b="0" u="none" strike="noStrike">
+              <a:solidFill>
+                <a:srgbClr val="FFFFFF"/>
+              </a:solidFill>
+              <a:effectLst/>
+              <a:uFillTx/>
+              <a:latin typeface="Arial"/>
+            </a:endParaRPr>
+          </a:p>
+          <a:p>
+            <a:pPr algn="ctr">
+              <a:spcBef>
+                <a:spcPts val="1191"/>
+              </a:spcBef>
+              <a:spcAft>
+                <a:spcPts val="992"/>
+              </a:spcAft>
+            </a:pPr>
+            <a:endParaRPr lang="de-DE" sz="2200" b="0" u="none" strike="noStrike">
+              <a:solidFill>
+                <a:srgbClr val="FFFFFF"/>
+              </a:solidFill>
+              <a:effectLst/>
+              <a:uFillTx/>
+              <a:latin typeface="Arial"/>
+            </a:endParaRPr>
+          </a:p>
+          <a:p>
+            <a:pPr algn="ctr">
+              <a:spcBef>
+                <a:spcPts val="1191"/>
+              </a:spcBef>
+              <a:spcAft>
+                <a:spcPts val="992"/>
+              </a:spcAft>
+            </a:pPr>
+            <a:r>
+              <a:rPr lang="de-DE" sz="2200" b="0" u="none" strike="noStrike">
+                <a:solidFill>
+                  <a:srgbClr val="FFFFFF"/>
+                </a:solidFill>
+                <a:effectLst/>
+                <a:uFillTx/>
+                <a:latin typeface="Arial"/>
+              </a:rPr>
+              <a:t>End of the presentation</a:t>
+            </a:r>
+            <a:endParaRPr lang="de-DE" sz="2200" b="0" u="none" strike="noStrike">
+              <a:solidFill>
+                <a:srgbClr val="FFFFFF"/>
+              </a:solidFill>
+              <a:effectLst/>
+              <a:uFillTx/>
+              <a:latin typeface="Arial"/>
+            </a:endParaRPr>
+          </a:p>
+        </p:txBody>
+      </p:sp>
+    </p:spTree>
+  </p:cSld>
+  <mc:AlternateContent>
+    <mc:Choice Requires="p14">
+      <p:transition spd="slow" p14:dur="2000"/>
+    </mc:Choice>
+    <mc:Fallback>
+      <p:transition spd="slow"/>
+    </mc:Fallback>
+  </mc:AlternateContent>
+</p:sld>
+</file>
+
+<file path=ppt/slides/slide9.xml><?xml version="1.0" encoding="utf-8"?>
+<p:sld xmlns:a="http://schemas.openxmlformats.org/drawingml/2006/main" xmlns:p="http://schemas.openxmlformats.org/presentationml/2006/main" xmlns:r="http://schemas.openxmlformats.org/officeDocument/2006/relationships" xmlns:p14="http://schemas.microsoft.com/office/powerpoint/2010/main" xmlns:p15="http://schemas.microsoft.com/office/powerpoint/2012/main" xmlns:mc="http://schemas.openxmlformats.org/markup-compatibility/2006">
+  <p:cSld>
+    <p:bg>
+      <p:bgPr>
+        <a:gradFill rotWithShape="0">
+          <a:gsLst>
+            <a:gs pos="0">
+              <a:srgbClr val="729FCF"/>
+            </a:gs>
+            <a:gs pos="100000">
+              <a:srgbClr val="000000"/>
+            </a:gs>
+          </a:gsLst>
+          <a:path path="circle">
+            <a:fillToRect l="50000" t="50000" r="50000" b="50000"/>
+          </a:path>
+        </a:gradFill>
+      </p:bgPr>
+    </p:bg>
     <p:spTree>
       <p:nvGrpSpPr>
         <p:cNvPr id="1" name=""/>

</xml_diff>